<commit_message>
Add Smart Backlog Assistant case study deck
Co-authored-by: Copilot <223556219+Copilot@users.noreply.github.com>
</commit_message>
<xml_diff>
--- a/Smart_Backlog_Assistant_Case_Study.pptx
+++ b/Smart_Backlog_Assistant_Case_Study.pptx
@@ -1064,7 +1064,7 @@
           <a:p>
             <a:r>
               <a:rPr lang="en-US"/>
-              <a:t>This defense was strengthened after a plausible response rewrote a requirement and referenced an unknown backlog ID. Source comparison exposed the issue. Grounding checks, known-ID validation, typed categories, and negative tests now prevent that class of result from being accepted.</a:t>
+              <a:t>This defense was strengthened after a convincing-looking but incorrect response rewrote a requirement and referenced an unknown backlog ID. Source comparison exposed the issue. Grounding checks, known-ID validation, typed categories, and negative tests now prevent that class of result from being accepted.</a:t>
             </a:r>
           </a:p>
           <a:p>
@@ -11136,14 +11136,20 @@
           <a:p>
             <a:pPr algn="l"/>
             <a:r>
-              <a:rPr sz="1300" b="0">
+              <a:rPr lang="en-US" sz="1300" b="0">
                 <a:solidFill>
                   <a:srgbClr val="182230"/>
                 </a:solidFill>
                 <a:latin typeface="Aptos"/>
               </a:rPr>
-              <a:t>A plausible model response rewrote a requirement and referenced an unknown backlog ID. Source comparison exposed it; grounding, known-ID validation, typed allowlists, and negative tests now prevent recurrence.</a:t>
-            </a:r>
+              <a:t>A convincing-looking but incorrect model response rewrote a requirement and referenced an unknown backlog ID. Source comparison exposed it; grounding, known-ID validation, typed allowlists, and negative tests now prevent recurrence.</a:t>
+            </a:r>
+            <a:endParaRPr sz="1300" b="0">
+              <a:solidFill>
+                <a:srgbClr val="182230"/>
+              </a:solidFill>
+              <a:latin typeface="Aptos"/>
+            </a:endParaRPr>
           </a:p>
         </p:txBody>
       </p:sp>

</xml_diff>